<commit_message>
Last anaylsis of project
</commit_message>
<xml_diff>
--- a/Online coach site data/online-CoachSite.pptx
+++ b/Online coach site data/online-CoachSite.pptx
@@ -4,9 +4,13 @@
   <p:sldMasterIdLst>
     <p:sldMasterId id="2147483648" r:id="rId1"/>
   </p:sldMasterIdLst>
+  <p:notesMasterIdLst>
+    <p:notesMasterId r:id="rId5"/>
+  </p:notesMasterIdLst>
   <p:sldIdLst>
     <p:sldId id="256" r:id="rId2"/>
     <p:sldId id="257" r:id="rId3"/>
+    <p:sldId id="258" r:id="rId4"/>
   </p:sldIdLst>
   <p:sldSz cx="12192000" cy="6858000"/>
   <p:notesSz cx="6858000" cy="9144000"/>
@@ -105,7 +109,362 @@
       </a:defRPr>
     </a:lvl9pPr>
   </p:defaultTextStyle>
+  <p:extLst>
+    <p:ext uri="{EFAFB233-063F-42B5-8137-9DF3F51BA10A}">
+      <p15:sldGuideLst xmlns:p15="http://schemas.microsoft.com/office/powerpoint/2012/main"/>
+    </p:ext>
+  </p:extLst>
 </p:presentation>
+</file>
+
+<file path=ppt/notesMasters/notesMaster1.xml><?xml version="1.0" encoding="utf-8"?>
+<p:notesMaster xmlns:a="http://schemas.openxmlformats.org/drawingml/2006/main" xmlns:r="http://schemas.openxmlformats.org/officeDocument/2006/relationships" xmlns:p="http://schemas.openxmlformats.org/presentationml/2006/main">
+  <p:cSld>
+    <p:bg>
+      <p:bgRef idx="1001">
+        <a:schemeClr val="bg1"/>
+      </p:bgRef>
+    </p:bg>
+    <p:spTree>
+      <p:nvGrpSpPr>
+        <p:cNvPr id="1" name=""/>
+        <p:cNvGrpSpPr/>
+        <p:nvPr/>
+      </p:nvGrpSpPr>
+      <p:grpSpPr>
+        <a:xfrm>
+          <a:off x="0" y="0"/>
+          <a:ext cx="0" cy="0"/>
+          <a:chOff x="0" y="0"/>
+          <a:chExt cx="0" cy="0"/>
+        </a:xfrm>
+      </p:grpSpPr>
+      <p:sp>
+        <p:nvSpPr>
+          <p:cNvPr id="2" name="Header Placeholder 1"/>
+          <p:cNvSpPr>
+            <a:spLocks noGrp="1"/>
+          </p:cNvSpPr>
+          <p:nvPr>
+            <p:ph type="hdr" sz="quarter"/>
+          </p:nvPr>
+        </p:nvSpPr>
+        <p:spPr>
+          <a:xfrm>
+            <a:off x="0" y="0"/>
+            <a:ext cx="2971800" cy="458788"/>
+          </a:xfrm>
+          <a:prstGeom prst="rect">
+            <a:avLst/>
+          </a:prstGeom>
+        </p:spPr>
+        <p:txBody>
+          <a:bodyPr vert="horz" lIns="91440" tIns="45720" rIns="91440" bIns="45720" rtlCol="0"/>
+          <a:lstStyle>
+            <a:lvl1pPr algn="r">
+              <a:defRPr sz="1200"/>
+            </a:lvl1pPr>
+          </a:lstStyle>
+          <a:p>
+            <a:endParaRPr lang="ar-SA"/>
+          </a:p>
+        </p:txBody>
+      </p:sp>
+      <p:sp>
+        <p:nvSpPr>
+          <p:cNvPr id="3" name="Date Placeholder 2"/>
+          <p:cNvSpPr>
+            <a:spLocks noGrp="1"/>
+          </p:cNvSpPr>
+          <p:nvPr>
+            <p:ph type="dt" idx="1"/>
+          </p:nvPr>
+        </p:nvSpPr>
+        <p:spPr>
+          <a:xfrm>
+            <a:off x="3884613" y="0"/>
+            <a:ext cx="2971800" cy="458788"/>
+          </a:xfrm>
+          <a:prstGeom prst="rect">
+            <a:avLst/>
+          </a:prstGeom>
+        </p:spPr>
+        <p:txBody>
+          <a:bodyPr vert="horz" lIns="91440" tIns="45720" rIns="91440" bIns="45720" rtlCol="0"/>
+          <a:lstStyle>
+            <a:lvl1pPr algn="l">
+              <a:defRPr sz="1200"/>
+            </a:lvl1pPr>
+          </a:lstStyle>
+          <a:p>
+            <a:fld id="{DE9BD98D-83F8-4115-86CA-622B74CE17B1}" type="datetimeFigureOut">
+              <a:rPr lang="ar-SA" smtClean="0"/>
+              <a:t>23/02/1447</a:t>
+            </a:fld>
+            <a:endParaRPr lang="ar-SA"/>
+          </a:p>
+        </p:txBody>
+      </p:sp>
+      <p:sp>
+        <p:nvSpPr>
+          <p:cNvPr id="4" name="Slide Image Placeholder 3"/>
+          <p:cNvSpPr>
+            <a:spLocks noGrp="1" noRot="1" noChangeAspect="1"/>
+          </p:cNvSpPr>
+          <p:nvPr>
+            <p:ph type="sldImg" idx="2"/>
+          </p:nvPr>
+        </p:nvSpPr>
+        <p:spPr>
+          <a:xfrm>
+            <a:off x="685800" y="1143000"/>
+            <a:ext cx="5486400" cy="3086100"/>
+          </a:xfrm>
+          <a:prstGeom prst="rect">
+            <a:avLst/>
+          </a:prstGeom>
+          <a:noFill/>
+          <a:ln w="12700">
+            <a:solidFill>
+              <a:prstClr val="black"/>
+            </a:solidFill>
+          </a:ln>
+        </p:spPr>
+        <p:txBody>
+          <a:bodyPr vert="horz" lIns="91440" tIns="45720" rIns="91440" bIns="45720" rtlCol="0" anchor="ctr"/>
+          <a:lstStyle/>
+          <a:p>
+            <a:endParaRPr lang="ar-SA"/>
+          </a:p>
+        </p:txBody>
+      </p:sp>
+      <p:sp>
+        <p:nvSpPr>
+          <p:cNvPr id="5" name="Notes Placeholder 4"/>
+          <p:cNvSpPr>
+            <a:spLocks noGrp="1"/>
+          </p:cNvSpPr>
+          <p:nvPr>
+            <p:ph type="body" sz="quarter" idx="3"/>
+          </p:nvPr>
+        </p:nvSpPr>
+        <p:spPr>
+          <a:xfrm>
+            <a:off x="685800" y="4400550"/>
+            <a:ext cx="5486400" cy="3600450"/>
+          </a:xfrm>
+          <a:prstGeom prst="rect">
+            <a:avLst/>
+          </a:prstGeom>
+        </p:spPr>
+        <p:txBody>
+          <a:bodyPr vert="horz" lIns="91440" tIns="45720" rIns="91440" bIns="45720" rtlCol="0"/>
+          <a:lstStyle/>
+          <a:p>
+            <a:pPr lvl="0"/>
+            <a:r>
+              <a:rPr lang="en-US"/>
+              <a:t>Click to edit Master text styles</a:t>
+            </a:r>
+          </a:p>
+          <a:p>
+            <a:pPr lvl="1"/>
+            <a:r>
+              <a:rPr lang="en-US"/>
+              <a:t>Second level</a:t>
+            </a:r>
+          </a:p>
+          <a:p>
+            <a:pPr lvl="2"/>
+            <a:r>
+              <a:rPr lang="en-US"/>
+              <a:t>Third level</a:t>
+            </a:r>
+          </a:p>
+          <a:p>
+            <a:pPr lvl="3"/>
+            <a:r>
+              <a:rPr lang="en-US"/>
+              <a:t>Fourth level</a:t>
+            </a:r>
+          </a:p>
+          <a:p>
+            <a:pPr lvl="4"/>
+            <a:r>
+              <a:rPr lang="en-US"/>
+              <a:t>Fifth level</a:t>
+            </a:r>
+            <a:endParaRPr lang="ar-SA"/>
+          </a:p>
+        </p:txBody>
+      </p:sp>
+      <p:sp>
+        <p:nvSpPr>
+          <p:cNvPr id="6" name="Footer Placeholder 5"/>
+          <p:cNvSpPr>
+            <a:spLocks noGrp="1"/>
+          </p:cNvSpPr>
+          <p:nvPr>
+            <p:ph type="ftr" sz="quarter" idx="4"/>
+          </p:nvPr>
+        </p:nvSpPr>
+        <p:spPr>
+          <a:xfrm>
+            <a:off x="0" y="8685213"/>
+            <a:ext cx="2971800" cy="458787"/>
+          </a:xfrm>
+          <a:prstGeom prst="rect">
+            <a:avLst/>
+          </a:prstGeom>
+        </p:spPr>
+        <p:txBody>
+          <a:bodyPr vert="horz" lIns="91440" tIns="45720" rIns="91440" bIns="45720" rtlCol="0" anchor="b"/>
+          <a:lstStyle>
+            <a:lvl1pPr algn="r">
+              <a:defRPr sz="1200"/>
+            </a:lvl1pPr>
+          </a:lstStyle>
+          <a:p>
+            <a:endParaRPr lang="ar-SA"/>
+          </a:p>
+        </p:txBody>
+      </p:sp>
+      <p:sp>
+        <p:nvSpPr>
+          <p:cNvPr id="7" name="Slide Number Placeholder 6"/>
+          <p:cNvSpPr>
+            <a:spLocks noGrp="1"/>
+          </p:cNvSpPr>
+          <p:nvPr>
+            <p:ph type="sldNum" sz="quarter" idx="5"/>
+          </p:nvPr>
+        </p:nvSpPr>
+        <p:spPr>
+          <a:xfrm>
+            <a:off x="3884613" y="8685213"/>
+            <a:ext cx="2971800" cy="458787"/>
+          </a:xfrm>
+          <a:prstGeom prst="rect">
+            <a:avLst/>
+          </a:prstGeom>
+        </p:spPr>
+        <p:txBody>
+          <a:bodyPr vert="horz" lIns="91440" tIns="45720" rIns="91440" bIns="45720" rtlCol="0" anchor="b"/>
+          <a:lstStyle>
+            <a:lvl1pPr algn="l">
+              <a:defRPr sz="1200"/>
+            </a:lvl1pPr>
+          </a:lstStyle>
+          <a:p>
+            <a:fld id="{0A866DBE-6E6E-4F02-937B-74CC2A446A5F}" type="slidenum">
+              <a:rPr lang="ar-SA" smtClean="0"/>
+              <a:t>‹#›</a:t>
+            </a:fld>
+            <a:endParaRPr lang="ar-SA"/>
+          </a:p>
+        </p:txBody>
+      </p:sp>
+    </p:spTree>
+    <p:extLst>
+      <p:ext uri="{BB962C8B-B14F-4D97-AF65-F5344CB8AC3E}">
+        <p14:creationId xmlns:p14="http://schemas.microsoft.com/office/powerpoint/2010/main" val="2354419054"/>
+      </p:ext>
+    </p:extLst>
+  </p:cSld>
+  <p:clrMap bg1="lt1" tx1="dk1" bg2="lt2" tx2="dk2" accent1="accent1" accent2="accent2" accent3="accent3" accent4="accent4" accent5="accent5" accent6="accent6" hlink="hlink" folHlink="folHlink"/>
+  <p:notesStyle>
+    <a:lvl1pPr marL="0" algn="l" defTabSz="914400" rtl="0" eaLnBrk="1" latinLnBrk="0" hangingPunct="1">
+      <a:defRPr sz="1200" kern="1200">
+        <a:solidFill>
+          <a:schemeClr val="tx1"/>
+        </a:solidFill>
+        <a:latin typeface="+mn-lt"/>
+        <a:ea typeface="+mn-ea"/>
+        <a:cs typeface="+mn-cs"/>
+      </a:defRPr>
+    </a:lvl1pPr>
+    <a:lvl2pPr marL="457200" algn="l" defTabSz="914400" rtl="0" eaLnBrk="1" latinLnBrk="0" hangingPunct="1">
+      <a:defRPr sz="1200" kern="1200">
+        <a:solidFill>
+          <a:schemeClr val="tx1"/>
+        </a:solidFill>
+        <a:latin typeface="+mn-lt"/>
+        <a:ea typeface="+mn-ea"/>
+        <a:cs typeface="+mn-cs"/>
+      </a:defRPr>
+    </a:lvl2pPr>
+    <a:lvl3pPr marL="914400" algn="l" defTabSz="914400" rtl="0" eaLnBrk="1" latinLnBrk="0" hangingPunct="1">
+      <a:defRPr sz="1200" kern="1200">
+        <a:solidFill>
+          <a:schemeClr val="tx1"/>
+        </a:solidFill>
+        <a:latin typeface="+mn-lt"/>
+        <a:ea typeface="+mn-ea"/>
+        <a:cs typeface="+mn-cs"/>
+      </a:defRPr>
+    </a:lvl3pPr>
+    <a:lvl4pPr marL="1371600" algn="l" defTabSz="914400" rtl="0" eaLnBrk="1" latinLnBrk="0" hangingPunct="1">
+      <a:defRPr sz="1200" kern="1200">
+        <a:solidFill>
+          <a:schemeClr val="tx1"/>
+        </a:solidFill>
+        <a:latin typeface="+mn-lt"/>
+        <a:ea typeface="+mn-ea"/>
+        <a:cs typeface="+mn-cs"/>
+      </a:defRPr>
+    </a:lvl4pPr>
+    <a:lvl5pPr marL="1828800" algn="l" defTabSz="914400" rtl="0" eaLnBrk="1" latinLnBrk="0" hangingPunct="1">
+      <a:defRPr sz="1200" kern="1200">
+        <a:solidFill>
+          <a:schemeClr val="tx1"/>
+        </a:solidFill>
+        <a:latin typeface="+mn-lt"/>
+        <a:ea typeface="+mn-ea"/>
+        <a:cs typeface="+mn-cs"/>
+      </a:defRPr>
+    </a:lvl5pPr>
+    <a:lvl6pPr marL="2286000" algn="l" defTabSz="914400" rtl="0" eaLnBrk="1" latinLnBrk="0" hangingPunct="1">
+      <a:defRPr sz="1200" kern="1200">
+        <a:solidFill>
+          <a:schemeClr val="tx1"/>
+        </a:solidFill>
+        <a:latin typeface="+mn-lt"/>
+        <a:ea typeface="+mn-ea"/>
+        <a:cs typeface="+mn-cs"/>
+      </a:defRPr>
+    </a:lvl6pPr>
+    <a:lvl7pPr marL="2743200" algn="l" defTabSz="914400" rtl="0" eaLnBrk="1" latinLnBrk="0" hangingPunct="1">
+      <a:defRPr sz="1200" kern="1200">
+        <a:solidFill>
+          <a:schemeClr val="tx1"/>
+        </a:solidFill>
+        <a:latin typeface="+mn-lt"/>
+        <a:ea typeface="+mn-ea"/>
+        <a:cs typeface="+mn-cs"/>
+      </a:defRPr>
+    </a:lvl7pPr>
+    <a:lvl8pPr marL="3200400" algn="l" defTabSz="914400" rtl="0" eaLnBrk="1" latinLnBrk="0" hangingPunct="1">
+      <a:defRPr sz="1200" kern="1200">
+        <a:solidFill>
+          <a:schemeClr val="tx1"/>
+        </a:solidFill>
+        <a:latin typeface="+mn-lt"/>
+        <a:ea typeface="+mn-ea"/>
+        <a:cs typeface="+mn-cs"/>
+      </a:defRPr>
+    </a:lvl8pPr>
+    <a:lvl9pPr marL="3657600" algn="l" defTabSz="914400" rtl="0" eaLnBrk="1" latinLnBrk="0" hangingPunct="1">
+      <a:defRPr sz="1200" kern="1200">
+        <a:solidFill>
+          <a:schemeClr val="tx1"/>
+        </a:solidFill>
+        <a:latin typeface="+mn-lt"/>
+        <a:ea typeface="+mn-ea"/>
+        <a:cs typeface="+mn-cs"/>
+      </a:defRPr>
+    </a:lvl9pPr>
+  </p:notesStyle>
+</p:notesMaster>
 </file>
 
 <file path=ppt/slideLayouts/slideLayout1.xml><?xml version="1.0" encoding="utf-8"?>
@@ -255,7 +614,7 @@
           <a:p>
             <a:fld id="{18E22DAC-304F-4F52-9F26-8C8B8FABCF90}" type="datetimeFigureOut">
               <a:rPr lang="en-US" smtClean="0"/>
-              <a:t>8/12/2025</a:t>
+              <a:t>8/17/2025</a:t>
             </a:fld>
             <a:endParaRPr lang="en-US"/>
           </a:p>
@@ -453,7 +812,7 @@
           <a:p>
             <a:fld id="{18E22DAC-304F-4F52-9F26-8C8B8FABCF90}" type="datetimeFigureOut">
               <a:rPr lang="en-US" smtClean="0"/>
-              <a:t>8/12/2025</a:t>
+              <a:t>8/17/2025</a:t>
             </a:fld>
             <a:endParaRPr lang="en-US"/>
           </a:p>
@@ -661,7 +1020,7 @@
           <a:p>
             <a:fld id="{18E22DAC-304F-4F52-9F26-8C8B8FABCF90}" type="datetimeFigureOut">
               <a:rPr lang="en-US" smtClean="0"/>
-              <a:t>8/12/2025</a:t>
+              <a:t>8/17/2025</a:t>
             </a:fld>
             <a:endParaRPr lang="en-US"/>
           </a:p>
@@ -859,7 +1218,7 @@
           <a:p>
             <a:fld id="{18E22DAC-304F-4F52-9F26-8C8B8FABCF90}" type="datetimeFigureOut">
               <a:rPr lang="en-US" smtClean="0"/>
-              <a:t>8/12/2025</a:t>
+              <a:t>8/17/2025</a:t>
             </a:fld>
             <a:endParaRPr lang="en-US"/>
           </a:p>
@@ -1134,7 +1493,7 @@
           <a:p>
             <a:fld id="{18E22DAC-304F-4F52-9F26-8C8B8FABCF90}" type="datetimeFigureOut">
               <a:rPr lang="en-US" smtClean="0"/>
-              <a:t>8/12/2025</a:t>
+              <a:t>8/17/2025</a:t>
             </a:fld>
             <a:endParaRPr lang="en-US"/>
           </a:p>
@@ -1399,7 +1758,7 @@
           <a:p>
             <a:fld id="{18E22DAC-304F-4F52-9F26-8C8B8FABCF90}" type="datetimeFigureOut">
               <a:rPr lang="en-US" smtClean="0"/>
-              <a:t>8/12/2025</a:t>
+              <a:t>8/17/2025</a:t>
             </a:fld>
             <a:endParaRPr lang="en-US"/>
           </a:p>
@@ -1811,7 +2170,7 @@
           <a:p>
             <a:fld id="{18E22DAC-304F-4F52-9F26-8C8B8FABCF90}" type="datetimeFigureOut">
               <a:rPr lang="en-US" smtClean="0"/>
-              <a:t>8/12/2025</a:t>
+              <a:t>8/17/2025</a:t>
             </a:fld>
             <a:endParaRPr lang="en-US"/>
           </a:p>
@@ -1952,7 +2311,7 @@
           <a:p>
             <a:fld id="{18E22DAC-304F-4F52-9F26-8C8B8FABCF90}" type="datetimeFigureOut">
               <a:rPr lang="en-US" smtClean="0"/>
-              <a:t>8/12/2025</a:t>
+              <a:t>8/17/2025</a:t>
             </a:fld>
             <a:endParaRPr lang="en-US"/>
           </a:p>
@@ -2065,7 +2424,7 @@
           <a:p>
             <a:fld id="{18E22DAC-304F-4F52-9F26-8C8B8FABCF90}" type="datetimeFigureOut">
               <a:rPr lang="en-US" smtClean="0"/>
-              <a:t>8/12/2025</a:t>
+              <a:t>8/17/2025</a:t>
             </a:fld>
             <a:endParaRPr lang="en-US"/>
           </a:p>
@@ -2376,7 +2735,7 @@
           <a:p>
             <a:fld id="{18E22DAC-304F-4F52-9F26-8C8B8FABCF90}" type="datetimeFigureOut">
               <a:rPr lang="en-US" smtClean="0"/>
-              <a:t>8/12/2025</a:t>
+              <a:t>8/17/2025</a:t>
             </a:fld>
             <a:endParaRPr lang="en-US"/>
           </a:p>
@@ -2664,7 +3023,7 @@
           <a:p>
             <a:fld id="{18E22DAC-304F-4F52-9F26-8C8B8FABCF90}" type="datetimeFigureOut">
               <a:rPr lang="en-US" smtClean="0"/>
-              <a:t>8/12/2025</a:t>
+              <a:t>8/17/2025</a:t>
             </a:fld>
             <a:endParaRPr lang="en-US"/>
           </a:p>
@@ -2905,7 +3264,7 @@
           <a:p>
             <a:fld id="{18E22DAC-304F-4F52-9F26-8C8B8FABCF90}" type="datetimeFigureOut">
               <a:rPr lang="en-US" smtClean="0"/>
-              <a:t>8/12/2025</a:t>
+              <a:t>8/17/2025</a:t>
             </a:fld>
             <a:endParaRPr lang="en-US"/>
           </a:p>
@@ -3354,6 +3713,83 @@
           </a:p>
         </p:txBody>
       </p:sp>
+      <p:sp>
+        <p:nvSpPr>
+          <p:cNvPr id="2" name="TextBox 1">
+            <a:extLst>
+              <a:ext uri="{FF2B5EF4-FFF2-40B4-BE49-F238E27FC236}">
+                <a16:creationId xmlns:a16="http://schemas.microsoft.com/office/drawing/2014/main" id="{FABD2B4B-554F-6CE5-CE6C-4372990D98C6}"/>
+              </a:ext>
+            </a:extLst>
+          </p:cNvPr>
+          <p:cNvSpPr txBox="1"/>
+          <p:nvPr/>
+        </p:nvSpPr>
+        <p:spPr>
+          <a:xfrm>
+            <a:off x="843379" y="497202"/>
+            <a:ext cx="10306974" cy="646331"/>
+          </a:xfrm>
+          <a:prstGeom prst="rect">
+            <a:avLst/>
+          </a:prstGeom>
+          <a:noFill/>
+        </p:spPr>
+        <p:txBody>
+          <a:bodyPr wrap="square" rtlCol="1">
+            <a:spAutoFit/>
+          </a:bodyPr>
+          <a:lstStyle/>
+          <a:p>
+            <a:pPr algn="ctr"/>
+            <a:r>
+              <a:rPr lang="en-US" sz="3600" b="1" dirty="0" err="1"/>
+              <a:t>Anaylsis</a:t>
+            </a:r>
+            <a:r>
+              <a:rPr lang="en-US" sz="3600" b="1" dirty="0"/>
+              <a:t> of Online coach site </a:t>
+            </a:r>
+            <a:endParaRPr lang="ar-SA" sz="3600" b="1" dirty="0"/>
+          </a:p>
+        </p:txBody>
+      </p:sp>
+      <p:pic>
+        <p:nvPicPr>
+          <p:cNvPr id="5" name="Picture 4">
+            <a:extLst>
+              <a:ext uri="{FF2B5EF4-FFF2-40B4-BE49-F238E27FC236}">
+                <a16:creationId xmlns:a16="http://schemas.microsoft.com/office/drawing/2014/main" id="{3A0AEF2E-1C30-3CCA-E5DE-B1AD7E306A4F}"/>
+              </a:ext>
+            </a:extLst>
+          </p:cNvPr>
+          <p:cNvPicPr>
+            <a:picLocks noChangeAspect="1"/>
+          </p:cNvPicPr>
+          <p:nvPr/>
+        </p:nvPicPr>
+        <p:blipFill>
+          <a:blip r:embed="rId2">
+            <a:extLst>
+              <a:ext uri="{28A0092B-C50C-407E-A947-70E740481C1C}">
+                <a14:useLocalDpi xmlns:a14="http://schemas.microsoft.com/office/drawing/2010/main" val="0"/>
+              </a:ext>
+            </a:extLst>
+          </a:blip>
+          <a:stretch>
+            <a:fillRect/>
+          </a:stretch>
+        </p:blipFill>
+        <p:spPr>
+          <a:xfrm>
+            <a:off x="0" y="2159000"/>
+            <a:ext cx="12192000" cy="2540000"/>
+          </a:xfrm>
+          <a:prstGeom prst="rect">
+            <a:avLst/>
+          </a:prstGeom>
+        </p:spPr>
+      </p:pic>
     </p:spTree>
     <p:extLst>
       <p:ext uri="{BB962C8B-B14F-4D97-AF65-F5344CB8AC3E}">
@@ -3404,8 +3840,8 @@
         </p:nvSpPr>
         <p:spPr>
           <a:xfrm>
-            <a:off x="181947" y="93307"/>
-            <a:ext cx="11611947" cy="6199005"/>
+            <a:off x="121350" y="0"/>
+            <a:ext cx="11611947" cy="6757747"/>
           </a:xfrm>
           <a:prstGeom prst="rect">
             <a:avLst/>
@@ -3418,149 +3854,170 @@
           </a:bodyPr>
           <a:lstStyle/>
           <a:p>
+            <a:pPr marL="171450" indent="-171450">
+              <a:lnSpc>
+                <a:spcPct val="150000"/>
+              </a:lnSpc>
+              <a:buFontTx/>
+              <a:buChar char="-"/>
+            </a:pPr>
+            <a:r>
+              <a:rPr lang="en-US" sz="1400" dirty="0">
+                <a:latin typeface="Arial Black" panose="020B0A04020102020204" pitchFamily="34" charset="0"/>
+              </a:rPr>
+              <a:t>My project is a </a:t>
+            </a:r>
+            <a:r>
+              <a:rPr lang="en-US" sz="1400" b="1" dirty="0">
+                <a:latin typeface="Arial Black" panose="020B0A04020102020204" pitchFamily="34" charset="0"/>
+              </a:rPr>
+              <a:t>comprehensive personal coaching platform</a:t>
+            </a:r>
+            <a:r>
+              <a:rPr lang="en-US" sz="1400" dirty="0">
+                <a:latin typeface="Arial Black" panose="020B0A04020102020204" pitchFamily="34" charset="0"/>
+              </a:rPr>
+              <a:t> where coaches can offer three primary services: </a:t>
+            </a:r>
+            <a:r>
+              <a:rPr lang="en-US" sz="1400" b="1" dirty="0">
+                <a:latin typeface="Arial Black" panose="020B0A04020102020204" pitchFamily="34" charset="0"/>
+              </a:rPr>
+              <a:t>online coaching packages, courses, and digital books</a:t>
+            </a:r>
+            <a:r>
+              <a:rPr lang="en-US" sz="1400" dirty="0">
+                <a:latin typeface="Arial Black" panose="020B0A04020102020204" pitchFamily="34" charset="0"/>
+              </a:rPr>
+              <a:t>. Clients can register and choose any combination of services—subscribing to online coaching, purchasing books, enrolling in courses, or combining these options. For online coaching, the coach creates and lists multiple subscription packages (e.g., 1 month, 2 months, 3 months, up to 1 year), each with a specific price and detailed description. Once a client selects a package and submits a request, the coach reviews and approves it. Upon approval, the client is presented with a </a:t>
+            </a:r>
+            <a:r>
+              <a:rPr lang="en-US" sz="1400" b="1" dirty="0">
+                <a:latin typeface="Arial Black" panose="020B0A04020102020204" pitchFamily="34" charset="0"/>
+              </a:rPr>
+              <a:t>customized questionnaire</a:t>
+            </a:r>
+            <a:r>
+              <a:rPr lang="en-US" sz="1400" dirty="0">
+                <a:latin typeface="Arial Black" panose="020B0A04020102020204" pitchFamily="34" charset="0"/>
+              </a:rPr>
+              <a:t> prepared by the coach, and based on the responses, the coach assigns a </a:t>
+            </a:r>
+            <a:r>
+              <a:rPr lang="en-US" sz="1400" b="1" dirty="0">
+                <a:latin typeface="Arial Black" panose="020B0A04020102020204" pitchFamily="34" charset="0"/>
+              </a:rPr>
+              <a:t>personalized nutrition and exercise program</a:t>
+            </a:r>
+            <a:r>
+              <a:rPr lang="en-US" sz="1400" dirty="0">
+                <a:latin typeface="Arial Black" panose="020B0A04020102020204" pitchFamily="34" charset="0"/>
+              </a:rPr>
+              <a:t> from a predefined database of workouts and meal plans. Online coaching access is time-limited, automatically locking upon subscription expiry. For books, clients browse the available library, submit purchase requests for desired titles, and upon coach approval, receive </a:t>
+            </a:r>
+            <a:r>
+              <a:rPr lang="en-US" sz="1400" b="1" dirty="0">
+                <a:latin typeface="Arial Black" panose="020B0A04020102020204" pitchFamily="34" charset="0"/>
+              </a:rPr>
+              <a:t>view-only embedded access</a:t>
+            </a:r>
+            <a:r>
+              <a:rPr lang="en-US" sz="1400" dirty="0">
+                <a:latin typeface="Arial Black" panose="020B0A04020102020204" pitchFamily="34" charset="0"/>
+              </a:rPr>
+              <a:t> with strict anti-download and anti-copy protection. Similarly, for courses, clients can request enrollment, and once approved, gain </a:t>
+            </a:r>
+            <a:r>
+              <a:rPr lang="en-US" sz="1400" b="1" dirty="0">
+                <a:latin typeface="Arial Black" panose="020B0A04020102020204" pitchFamily="34" charset="0"/>
+              </a:rPr>
+              <a:t>permanent access</a:t>
+            </a:r>
+            <a:r>
+              <a:rPr lang="en-US" sz="1400" dirty="0">
+                <a:latin typeface="Arial Black" panose="020B0A04020102020204" pitchFamily="34" charset="0"/>
+              </a:rPr>
+              <a:t> to course materials. Both books and courses offer a </a:t>
+            </a:r>
+            <a:r>
+              <a:rPr lang="en-US" sz="1400" b="1" dirty="0">
+                <a:latin typeface="Arial Black" panose="020B0A04020102020204" pitchFamily="34" charset="0"/>
+              </a:rPr>
+              <a:t>free demo preview</a:t>
+            </a:r>
+            <a:r>
+              <a:rPr lang="en-US" sz="1400" dirty="0">
+                <a:latin typeface="Arial Black" panose="020B0A04020102020204" pitchFamily="34" charset="0"/>
+              </a:rPr>
+              <a:t>, allowing partial access before purchase. The platform tracks course progress, and when a client completes all videos, the system logs them in a </a:t>
+            </a:r>
+            <a:r>
+              <a:rPr lang="en-US" sz="1400" b="1" dirty="0">
+                <a:latin typeface="Arial Black" panose="020B0A04020102020204" pitchFamily="34" charset="0"/>
+              </a:rPr>
+              <a:t>course completion dashboard</a:t>
+            </a:r>
+            <a:r>
+              <a:rPr lang="en-US" sz="1400" dirty="0">
+                <a:latin typeface="Arial Black" panose="020B0A04020102020204" pitchFamily="34" charset="0"/>
+              </a:rPr>
+              <a:t> visible to the coach. Additional features include </a:t>
+            </a:r>
+            <a:r>
+              <a:rPr lang="en-US" sz="1400" b="1" dirty="0">
+                <a:latin typeface="Arial Black" panose="020B0A04020102020204" pitchFamily="34" charset="0"/>
+              </a:rPr>
+              <a:t>in-app notifications</a:t>
+            </a:r>
+            <a:r>
+              <a:rPr lang="en-US" sz="1400" dirty="0">
+                <a:latin typeface="Arial Black" panose="020B0A04020102020204" pitchFamily="34" charset="0"/>
+              </a:rPr>
+              <a:t> for approvals, plan updates, and subscription expiry reminders; a </a:t>
+            </a:r>
+            <a:r>
+              <a:rPr lang="en-US" sz="1400" b="1" dirty="0">
+                <a:latin typeface="Arial Black" panose="020B0A04020102020204" pitchFamily="34" charset="0"/>
+              </a:rPr>
+              <a:t>built-in messaging system</a:t>
+            </a:r>
+            <a:r>
+              <a:rPr lang="en-US" sz="1400" dirty="0">
+                <a:latin typeface="Arial Black" panose="020B0A04020102020204" pitchFamily="34" charset="0"/>
+              </a:rPr>
+              <a:t> allowing clients to leave comments or feedback on their programs, which the coach can view in real time; and </a:t>
+            </a:r>
+            <a:r>
+              <a:rPr lang="en-US" sz="1400" b="1" dirty="0">
+                <a:latin typeface="Arial Black" panose="020B0A04020102020204" pitchFamily="34" charset="0"/>
+              </a:rPr>
+              <a:t>secure role-based access control</a:t>
+            </a:r>
+            <a:r>
+              <a:rPr lang="en-US" sz="1400" dirty="0">
+                <a:latin typeface="Arial Black" panose="020B0A04020102020204" pitchFamily="34" charset="0"/>
+              </a:rPr>
+              <a:t> to ensure proper permissions for clients and coaches. Coaches can efficiently reuse resources—such as exercises, meal plans, and course materials—without re-entering data for each client, and clients have a unified dashboard displaying approved services, subscription details, purchased courses, and books.</a:t>
+            </a:r>
+            <a:r>
+              <a:rPr lang="en-US" sz="1200" dirty="0">
+                <a:latin typeface="Arial Black" panose="020B0A04020102020204" pitchFamily="34" charset="0"/>
+              </a:rPr>
+              <a:t> </a:t>
+            </a:r>
+            <a:r>
+              <a:rPr lang="en-US" sz="1400" dirty="0">
+                <a:latin typeface="Arial Black" panose="020B0A04020102020204" pitchFamily="34" charset="0"/>
+              </a:rPr>
+              <a:t>Add service of transformation image before and after Add service that make client give his feedback about coach </a:t>
+            </a:r>
+          </a:p>
+          <a:p>
             <a:pPr>
               <a:lnSpc>
                 <a:spcPct val="150000"/>
               </a:lnSpc>
             </a:pPr>
-            <a:r>
-              <a:rPr lang="en-US" sz="1400" dirty="0">
-                <a:latin typeface="Arial Black" panose="020B0A04020102020204" pitchFamily="34" charset="0"/>
-              </a:rPr>
-              <a:t>My project is a </a:t>
-            </a:r>
-            <a:r>
-              <a:rPr lang="en-US" sz="1400" b="1" dirty="0">
-                <a:latin typeface="Arial Black" panose="020B0A04020102020204" pitchFamily="34" charset="0"/>
-              </a:rPr>
-              <a:t>comprehensive personal coaching platform</a:t>
-            </a:r>
-            <a:r>
-              <a:rPr lang="en-US" sz="1400" dirty="0">
-                <a:latin typeface="Arial Black" panose="020B0A04020102020204" pitchFamily="34" charset="0"/>
-              </a:rPr>
-              <a:t> where coaches can offer three primary services: </a:t>
-            </a:r>
-            <a:r>
-              <a:rPr lang="en-US" sz="1400" b="1" dirty="0">
-                <a:latin typeface="Arial Black" panose="020B0A04020102020204" pitchFamily="34" charset="0"/>
-              </a:rPr>
-              <a:t>online coaching packages, courses, and digital books</a:t>
-            </a:r>
-            <a:r>
-              <a:rPr lang="en-US" sz="1400" dirty="0">
-                <a:latin typeface="Arial Black" panose="020B0A04020102020204" pitchFamily="34" charset="0"/>
-              </a:rPr>
-              <a:t>. Clients can register and choose any combination of services—subscribing to online coaching, purchasing books, enrolling in courses, or combining these options. For online coaching, the coach creates and lists multiple subscription packages (e.g., 1 month, 2 months, 3 months, up to 1 year), each with a specific price and detailed description. Once a client selects a package and submits a request, the coach reviews and approves it. Upon approval, the client is presented with a </a:t>
-            </a:r>
-            <a:r>
-              <a:rPr lang="en-US" sz="1400" b="1" dirty="0">
-                <a:latin typeface="Arial Black" panose="020B0A04020102020204" pitchFamily="34" charset="0"/>
-              </a:rPr>
-              <a:t>customized questionnaire</a:t>
-            </a:r>
-            <a:r>
-              <a:rPr lang="en-US" sz="1400" dirty="0">
-                <a:latin typeface="Arial Black" panose="020B0A04020102020204" pitchFamily="34" charset="0"/>
-              </a:rPr>
-              <a:t> prepared by the coach, and based on the responses, the coach assigns a </a:t>
-            </a:r>
-            <a:r>
-              <a:rPr lang="en-US" sz="1400" b="1" dirty="0">
-                <a:latin typeface="Arial Black" panose="020B0A04020102020204" pitchFamily="34" charset="0"/>
-              </a:rPr>
-              <a:t>personalized nutrition and exercise program</a:t>
-            </a:r>
-            <a:r>
-              <a:rPr lang="en-US" sz="1400" dirty="0">
-                <a:latin typeface="Arial Black" panose="020B0A04020102020204" pitchFamily="34" charset="0"/>
-              </a:rPr>
-              <a:t> from a predefined database of workouts and meal plans. Online coaching access is time-limited, automatically locking upon subscription expiry. For books, clients browse the available library, submit purchase requests for desired titles, and upon coach approval, receive </a:t>
-            </a:r>
-            <a:r>
-              <a:rPr lang="en-US" sz="1400" b="1" dirty="0">
-                <a:latin typeface="Arial Black" panose="020B0A04020102020204" pitchFamily="34" charset="0"/>
-              </a:rPr>
-              <a:t>view-only embedded access</a:t>
-            </a:r>
-            <a:r>
-              <a:rPr lang="en-US" sz="1400" dirty="0">
-                <a:latin typeface="Arial Black" panose="020B0A04020102020204" pitchFamily="34" charset="0"/>
-              </a:rPr>
-              <a:t> with strict anti-download and anti-copy protection. Similarly, for courses, clients can request enrollment, and once approved, gain </a:t>
-            </a:r>
-            <a:r>
-              <a:rPr lang="en-US" sz="1400" b="1" dirty="0">
-                <a:latin typeface="Arial Black" panose="020B0A04020102020204" pitchFamily="34" charset="0"/>
-              </a:rPr>
-              <a:t>permanent access</a:t>
-            </a:r>
-            <a:r>
-              <a:rPr lang="en-US" sz="1400" dirty="0">
-                <a:latin typeface="Arial Black" panose="020B0A04020102020204" pitchFamily="34" charset="0"/>
-              </a:rPr>
-              <a:t> to course materials. Both books and courses offer a </a:t>
-            </a:r>
-            <a:r>
-              <a:rPr lang="en-US" sz="1400" b="1" dirty="0">
-                <a:latin typeface="Arial Black" panose="020B0A04020102020204" pitchFamily="34" charset="0"/>
-              </a:rPr>
-              <a:t>free demo preview</a:t>
-            </a:r>
-            <a:r>
-              <a:rPr lang="en-US" sz="1400" dirty="0">
-                <a:latin typeface="Arial Black" panose="020B0A04020102020204" pitchFamily="34" charset="0"/>
-              </a:rPr>
-              <a:t>, allowing partial access before purchase. The platform tracks course progress, and when a client completes all videos, the system logs them in a </a:t>
-            </a:r>
-            <a:r>
-              <a:rPr lang="en-US" sz="1400" b="1" dirty="0">
-                <a:latin typeface="Arial Black" panose="020B0A04020102020204" pitchFamily="34" charset="0"/>
-              </a:rPr>
-              <a:t>course completion dashboard</a:t>
-            </a:r>
-            <a:r>
-              <a:rPr lang="en-US" sz="1400" dirty="0">
-                <a:latin typeface="Arial Black" panose="020B0A04020102020204" pitchFamily="34" charset="0"/>
-              </a:rPr>
-              <a:t> visible to the coach. Additional features include </a:t>
-            </a:r>
-            <a:r>
-              <a:rPr lang="en-US" sz="1400" b="1" dirty="0">
-                <a:latin typeface="Arial Black" panose="020B0A04020102020204" pitchFamily="34" charset="0"/>
-              </a:rPr>
-              <a:t>in-app notifications</a:t>
-            </a:r>
-            <a:r>
-              <a:rPr lang="en-US" sz="1400" dirty="0">
-                <a:latin typeface="Arial Black" panose="020B0A04020102020204" pitchFamily="34" charset="0"/>
-              </a:rPr>
-              <a:t> for approvals, plan updates, and subscription expiry reminders; a </a:t>
-            </a:r>
-            <a:r>
-              <a:rPr lang="en-US" sz="1400" b="1" dirty="0">
-                <a:latin typeface="Arial Black" panose="020B0A04020102020204" pitchFamily="34" charset="0"/>
-              </a:rPr>
-              <a:t>built-in messaging system</a:t>
-            </a:r>
-            <a:r>
-              <a:rPr lang="en-US" sz="1400" dirty="0">
-                <a:latin typeface="Arial Black" panose="020B0A04020102020204" pitchFamily="34" charset="0"/>
-              </a:rPr>
-              <a:t> allowing clients to leave comments or feedback on their programs, which the coach can view in real time; and </a:t>
-            </a:r>
-            <a:r>
-              <a:rPr lang="en-US" sz="1400" b="1" dirty="0">
-                <a:latin typeface="Arial Black" panose="020B0A04020102020204" pitchFamily="34" charset="0"/>
-              </a:rPr>
-              <a:t>secure role-based access control</a:t>
-            </a:r>
-            <a:r>
-              <a:rPr lang="en-US" sz="1400" dirty="0">
-                <a:latin typeface="Arial Black" panose="020B0A04020102020204" pitchFamily="34" charset="0"/>
-              </a:rPr>
-              <a:t> to ensure proper permissions for clients and coaches. Coaches can efficiently reuse resources—such as exercises, meal plans, and course materials—without re-entering data for each client, and clients have a unified dashboard displaying approved services, subscription details, purchased courses, and books.</a:t>
-            </a:r>
             <a:endParaRPr lang="en-US" sz="1200" dirty="0">
               <a:latin typeface="Arial Black" panose="020B0A04020102020204" pitchFamily="34" charset="0"/>
             </a:endParaRPr>
@@ -3571,6 +4028,371 @@
     <p:extLst>
       <p:ext uri="{BB962C8B-B14F-4D97-AF65-F5344CB8AC3E}">
         <p14:creationId xmlns:p14="http://schemas.microsoft.com/office/powerpoint/2010/main" val="1138268754"/>
+      </p:ext>
+    </p:extLst>
+  </p:cSld>
+  <p:clrMapOvr>
+    <a:masterClrMapping/>
+  </p:clrMapOvr>
+</p:sld>
+</file>
+
+<file path=ppt/slides/slide3.xml><?xml version="1.0" encoding="utf-8"?>
+<p:sld xmlns:a="http://schemas.openxmlformats.org/drawingml/2006/main" xmlns:r="http://schemas.openxmlformats.org/officeDocument/2006/relationships" xmlns:p="http://schemas.openxmlformats.org/presentationml/2006/main">
+  <p:cSld>
+    <p:spTree>
+      <p:nvGrpSpPr>
+        <p:cNvPr id="1" name=""/>
+        <p:cNvGrpSpPr/>
+        <p:nvPr/>
+      </p:nvGrpSpPr>
+      <p:grpSpPr>
+        <a:xfrm>
+          <a:off x="0" y="0"/>
+          <a:ext cx="0" cy="0"/>
+          <a:chOff x="0" y="0"/>
+          <a:chExt cx="0" cy="0"/>
+        </a:xfrm>
+      </p:grpSpPr>
+      <p:sp>
+        <p:nvSpPr>
+          <p:cNvPr id="5" name="TextBox 4">
+            <a:extLst>
+              <a:ext uri="{FF2B5EF4-FFF2-40B4-BE49-F238E27FC236}">
+                <a16:creationId xmlns:a16="http://schemas.microsoft.com/office/drawing/2014/main" id="{81D57CF1-F7A7-0C20-9B8C-780BD3B5D273}"/>
+              </a:ext>
+            </a:extLst>
+          </p:cNvPr>
+          <p:cNvSpPr txBox="1"/>
+          <p:nvPr/>
+        </p:nvSpPr>
+        <p:spPr>
+          <a:xfrm>
+            <a:off x="181947" y="93307"/>
+            <a:ext cx="11611947" cy="1171603"/>
+          </a:xfrm>
+          <a:prstGeom prst="rect">
+            <a:avLst/>
+          </a:prstGeom>
+          <a:noFill/>
+        </p:spPr>
+        <p:txBody>
+          <a:bodyPr wrap="square" rtlCol="0">
+            <a:spAutoFit/>
+          </a:bodyPr>
+          <a:lstStyle/>
+          <a:p>
+            <a:pPr marL="171450" indent="-171450">
+              <a:lnSpc>
+                <a:spcPct val="150000"/>
+              </a:lnSpc>
+              <a:buFontTx/>
+              <a:buChar char="-"/>
+            </a:pPr>
+            <a:endParaRPr lang="en-US" sz="1200" dirty="0">
+              <a:latin typeface="Arial Black" panose="020B0A04020102020204" pitchFamily="34" charset="0"/>
+            </a:endParaRPr>
+          </a:p>
+          <a:p>
+            <a:pPr marL="171450" indent="-171450">
+              <a:lnSpc>
+                <a:spcPct val="150000"/>
+              </a:lnSpc>
+              <a:buFontTx/>
+              <a:buChar char="-"/>
+            </a:pPr>
+            <a:endParaRPr lang="en-US" sz="1200" dirty="0">
+              <a:latin typeface="Arial Black" panose="020B0A04020102020204" pitchFamily="34" charset="0"/>
+            </a:endParaRPr>
+          </a:p>
+          <a:p>
+            <a:pPr marL="171450" indent="-171450">
+              <a:lnSpc>
+                <a:spcPct val="150000"/>
+              </a:lnSpc>
+              <a:buFontTx/>
+              <a:buChar char="-"/>
+            </a:pPr>
+            <a:endParaRPr lang="en-US" sz="1200" dirty="0">
+              <a:latin typeface="Arial Black" panose="020B0A04020102020204" pitchFamily="34" charset="0"/>
+            </a:endParaRPr>
+          </a:p>
+          <a:p>
+            <a:pPr>
+              <a:lnSpc>
+                <a:spcPct val="150000"/>
+              </a:lnSpc>
+            </a:pPr>
+            <a:endParaRPr lang="en-US" sz="1200" dirty="0">
+              <a:latin typeface="Arial Black" panose="020B0A04020102020204" pitchFamily="34" charset="0"/>
+            </a:endParaRPr>
+          </a:p>
+        </p:txBody>
+      </p:sp>
+      <p:sp>
+        <p:nvSpPr>
+          <p:cNvPr id="3" name="Rectangle 2">
+            <a:extLst>
+              <a:ext uri="{FF2B5EF4-FFF2-40B4-BE49-F238E27FC236}">
+                <a16:creationId xmlns:a16="http://schemas.microsoft.com/office/drawing/2014/main" id="{511E6F06-E952-E90F-4353-E3E646EDE61E}"/>
+              </a:ext>
+            </a:extLst>
+          </p:cNvPr>
+          <p:cNvSpPr>
+            <a:spLocks noChangeArrowheads="1"/>
+          </p:cNvSpPr>
+          <p:nvPr/>
+        </p:nvSpPr>
+        <p:spPr bwMode="auto">
+          <a:xfrm>
+            <a:off x="181947" y="481081"/>
+            <a:ext cx="9820509" cy="3139321"/>
+          </a:xfrm>
+          <a:prstGeom prst="rect">
+            <a:avLst/>
+          </a:prstGeom>
+          <a:noFill/>
+          <a:ln>
+            <a:noFill/>
+          </a:ln>
+          <a:effectLst/>
+          <a:extLst>
+            <a:ext uri="{909E8E84-426E-40DD-AFC4-6F175D3DCCD1}">
+              <a14:hiddenFill xmlns:a14="http://schemas.microsoft.com/office/drawing/2010/main">
+                <a:solidFill>
+                  <a:schemeClr val="accent1"/>
+                </a:solidFill>
+              </a14:hiddenFill>
+            </a:ext>
+            <a:ext uri="{91240B29-F687-4F45-9708-019B960494DF}">
+              <a14:hiddenLine xmlns:a14="http://schemas.microsoft.com/office/drawing/2010/main" w="9525">
+                <a:solidFill>
+                  <a:schemeClr val="tx1"/>
+                </a:solidFill>
+                <a:miter lim="800000"/>
+                <a:headEnd/>
+                <a:tailEnd/>
+              </a14:hiddenLine>
+            </a:ext>
+            <a:ext uri="{AF507438-7753-43E0-B8FC-AC1667EBCBE1}">
+              <a14:hiddenEffects xmlns:a14="http://schemas.microsoft.com/office/drawing/2010/main">
+                <a:effectLst>
+                  <a:outerShdw dist="35921" dir="2700000" algn="ctr" rotWithShape="0">
+                    <a:schemeClr val="bg2"/>
+                  </a:outerShdw>
+                </a:effectLst>
+              </a14:hiddenEffects>
+            </a:ext>
+          </a:extLst>
+        </p:spPr>
+        <p:txBody>
+          <a:bodyPr vert="horz" wrap="none" lIns="91440" tIns="45720" rIns="91440" bIns="45720" numCol="1" anchor="ctr" anchorCtr="0" compatLnSpc="1">
+            <a:prstTxWarp prst="textNoShape">
+              <a:avLst/>
+            </a:prstTxWarp>
+            <a:spAutoFit/>
+          </a:bodyPr>
+          <a:lstStyle/>
+          <a:p>
+            <a:r>
+              <a:rPr lang="en-US" b="1" dirty="0" err="1"/>
+              <a:t>ApplicationUser</a:t>
+            </a:r>
+            <a:r>
+              <a:rPr lang="en-US" b="1" dirty="0"/>
+              <a:t> → Client → one-to-one (only for role = Client). </a:t>
+            </a:r>
+          </a:p>
+          <a:p>
+            <a:r>
+              <a:rPr lang="en-US" b="1" dirty="0"/>
+              <a:t>Client → </a:t>
+            </a:r>
+            <a:r>
+              <a:rPr lang="en-US" b="1" dirty="0" err="1"/>
+              <a:t>CoachingPackageRequest</a:t>
+            </a:r>
+            <a:r>
+              <a:rPr lang="en-US" b="1" dirty="0"/>
+              <a:t>, </a:t>
+            </a:r>
+            <a:r>
+              <a:rPr lang="en-US" b="1" dirty="0" err="1"/>
+              <a:t>BookRequest</a:t>
+            </a:r>
+            <a:r>
+              <a:rPr lang="en-US" b="1" dirty="0"/>
+              <a:t>, </a:t>
+            </a:r>
+            <a:r>
+              <a:rPr lang="en-US" b="1" dirty="0" err="1"/>
+              <a:t>CourseRequest</a:t>
+            </a:r>
+            <a:r>
+              <a:rPr lang="en-US" b="1" dirty="0"/>
+              <a:t> → one-to-many. </a:t>
+            </a:r>
+          </a:p>
+          <a:p>
+            <a:r>
+              <a:rPr lang="en-US" b="1" dirty="0" err="1"/>
+              <a:t>CoachingPackage</a:t>
+            </a:r>
+            <a:r>
+              <a:rPr lang="en-US" b="1" dirty="0"/>
+              <a:t> → </a:t>
+            </a:r>
+            <a:r>
+              <a:rPr lang="en-US" b="1" dirty="0" err="1"/>
+              <a:t>CoachingPackageRequest</a:t>
+            </a:r>
+            <a:r>
+              <a:rPr lang="en-US" b="1" dirty="0"/>
+              <a:t> → one-to-many. </a:t>
+            </a:r>
+          </a:p>
+          <a:p>
+            <a:r>
+              <a:rPr lang="en-US" b="1" dirty="0"/>
+              <a:t>Book → </a:t>
+            </a:r>
+            <a:r>
+              <a:rPr lang="en-US" b="1" dirty="0" err="1"/>
+              <a:t>BookRequest</a:t>
+            </a:r>
+            <a:r>
+              <a:rPr lang="en-US" b="1" dirty="0"/>
+              <a:t> →one-to-many. </a:t>
+            </a:r>
+          </a:p>
+          <a:p>
+            <a:r>
+              <a:rPr lang="en-US" b="1" dirty="0"/>
+              <a:t>Course → </a:t>
+            </a:r>
+            <a:r>
+              <a:rPr lang="en-US" b="1" dirty="0" err="1"/>
+              <a:t>CourseRequest</a:t>
+            </a:r>
+            <a:r>
+              <a:rPr lang="en-US" b="1" dirty="0"/>
+              <a:t>, </a:t>
+            </a:r>
+            <a:r>
+              <a:rPr lang="en-US" b="1" dirty="0" err="1"/>
+              <a:t>CourseVideo</a:t>
+            </a:r>
+            <a:r>
+              <a:rPr lang="en-US" b="1" dirty="0"/>
+              <a:t> → one-to-many. </a:t>
+            </a:r>
+          </a:p>
+          <a:p>
+            <a:r>
+              <a:rPr lang="en-US" b="1" dirty="0"/>
+              <a:t>Muscle → Exercise → one-to-many. </a:t>
+            </a:r>
+          </a:p>
+          <a:p>
+            <a:r>
+              <a:rPr lang="en-US" b="1" dirty="0"/>
+              <a:t>Exercise → </a:t>
+            </a:r>
+            <a:r>
+              <a:rPr lang="en-US" b="1" dirty="0" err="1"/>
+              <a:t>AssignExercise</a:t>
+            </a:r>
+            <a:r>
+              <a:rPr lang="en-US" b="1" dirty="0"/>
+              <a:t> → one-to-many. </a:t>
+            </a:r>
+          </a:p>
+          <a:p>
+            <a:r>
+              <a:rPr lang="en-US" b="1" dirty="0"/>
+              <a:t>Food → </a:t>
+            </a:r>
+            <a:r>
+              <a:rPr lang="en-US" b="1" dirty="0" err="1"/>
+              <a:t>AssignFood</a:t>
+            </a:r>
+            <a:r>
+              <a:rPr lang="en-US" b="1" dirty="0"/>
+              <a:t> → one-to-many. </a:t>
+            </a:r>
+          </a:p>
+          <a:p>
+            <a:r>
+              <a:rPr lang="en-US" b="1" dirty="0"/>
+              <a:t>Client → </a:t>
+            </a:r>
+            <a:r>
+              <a:rPr lang="en-US" b="1" dirty="0" err="1"/>
+              <a:t>AssignExercise</a:t>
+            </a:r>
+            <a:r>
+              <a:rPr lang="en-US" b="1" dirty="0"/>
+              <a:t>, </a:t>
+            </a:r>
+            <a:r>
+              <a:rPr lang="en-US" b="1" dirty="0" err="1"/>
+              <a:t>AssignFood</a:t>
+            </a:r>
+            <a:r>
+              <a:rPr lang="en-US" b="1" dirty="0"/>
+              <a:t>, Transformation, </a:t>
+            </a:r>
+            <a:r>
+              <a:rPr lang="en-US" b="1" dirty="0" err="1"/>
+              <a:t>CoachFeedback</a:t>
+            </a:r>
+            <a:r>
+              <a:rPr lang="en-US" b="1" dirty="0"/>
+              <a:t>, </a:t>
+            </a:r>
+            <a:r>
+              <a:rPr lang="en-US" b="1" dirty="0" err="1"/>
+              <a:t>ClientAnswer</a:t>
+            </a:r>
+            <a:r>
+              <a:rPr lang="en-US" b="1" dirty="0"/>
+              <a:t> → one-to-many. </a:t>
+            </a:r>
+          </a:p>
+          <a:p>
+            <a:r>
+              <a:rPr lang="en-US" b="1" dirty="0"/>
+              <a:t>Question → Option, </a:t>
+            </a:r>
+            <a:r>
+              <a:rPr lang="en-US" b="1" dirty="0" err="1"/>
+              <a:t>ClientAnswer</a:t>
+            </a:r>
+            <a:r>
+              <a:rPr lang="en-US" b="1" dirty="0"/>
+              <a:t> → one-to-many. </a:t>
+            </a:r>
+          </a:p>
+          <a:p>
+            <a:r>
+              <a:rPr lang="en-US" b="1" dirty="0"/>
+              <a:t>Option → </a:t>
+            </a:r>
+            <a:r>
+              <a:rPr lang="en-US" b="1" dirty="0" err="1"/>
+              <a:t>ClientAnswer</a:t>
+            </a:r>
+            <a:r>
+              <a:rPr lang="en-US" b="1" dirty="0"/>
+              <a:t> → one-to-many.</a:t>
+            </a:r>
+          </a:p>
+        </p:txBody>
+      </p:sp>
+    </p:spTree>
+    <p:extLst>
+      <p:ext uri="{BB962C8B-B14F-4D97-AF65-F5344CB8AC3E}">
+        <p14:creationId xmlns:p14="http://schemas.microsoft.com/office/powerpoint/2010/main" val="4134200298"/>
       </p:ext>
     </p:extLst>
   </p:cSld>
@@ -3873,4 +4695,299 @@
     </a:ext>
   </a:extLst>
 </a:theme>
+</file>
+
+<file path=ppt/theme/theme2.xml><?xml version="1.0" encoding="utf-8"?>
+<a:theme xmlns:a="http://schemas.openxmlformats.org/drawingml/2006/main" name="Office Theme">
+  <a:themeElements>
+    <a:clrScheme name="Office">
+      <a:dk1>
+        <a:sysClr val="windowText" lastClr="000000"/>
+      </a:dk1>
+      <a:lt1>
+        <a:sysClr val="window" lastClr="FFFFFF"/>
+      </a:lt1>
+      <a:dk2>
+        <a:srgbClr val="44546A"/>
+      </a:dk2>
+      <a:lt2>
+        <a:srgbClr val="E7E6E6"/>
+      </a:lt2>
+      <a:accent1>
+        <a:srgbClr val="4472C4"/>
+      </a:accent1>
+      <a:accent2>
+        <a:srgbClr val="ED7D31"/>
+      </a:accent2>
+      <a:accent3>
+        <a:srgbClr val="A5A5A5"/>
+      </a:accent3>
+      <a:accent4>
+        <a:srgbClr val="FFC000"/>
+      </a:accent4>
+      <a:accent5>
+        <a:srgbClr val="5B9BD5"/>
+      </a:accent5>
+      <a:accent6>
+        <a:srgbClr val="70AD47"/>
+      </a:accent6>
+      <a:hlink>
+        <a:srgbClr val="0563C1"/>
+      </a:hlink>
+      <a:folHlink>
+        <a:srgbClr val="954F72"/>
+      </a:folHlink>
+    </a:clrScheme>
+    <a:fontScheme name="Office">
+      <a:majorFont>
+        <a:latin typeface="Calibri Light" panose="020F0302020204030204"/>
+        <a:ea typeface=""/>
+        <a:cs typeface=""/>
+        <a:font script="Jpan" typeface="游ゴシック Light"/>
+        <a:font script="Hang" typeface="맑은 고딕"/>
+        <a:font script="Hans" typeface="等线 Light"/>
+        <a:font script="Hant" typeface="新細明體"/>
+        <a:font script="Arab" typeface="Times New Roman"/>
+        <a:font script="Hebr" typeface="Times New Roman"/>
+        <a:font script="Thai" typeface="Angsana New"/>
+        <a:font script="Ethi" typeface="Nyala"/>
+        <a:font script="Beng" typeface="Vrinda"/>
+        <a:font script="Gujr" typeface="Shruti"/>
+        <a:font script="Khmr" typeface="MoolBoran"/>
+        <a:font script="Knda" typeface="Tunga"/>
+        <a:font script="Guru" typeface="Raavi"/>
+        <a:font script="Cans" typeface="Euphemia"/>
+        <a:font script="Cher" typeface="Plantagenet Cherokee"/>
+        <a:font script="Yiii" typeface="Microsoft Yi Baiti"/>
+        <a:font script="Tibt" typeface="Microsoft Himalaya"/>
+        <a:font script="Thaa" typeface="MV Boli"/>
+        <a:font script="Deva" typeface="Mangal"/>
+        <a:font script="Telu" typeface="Gautami"/>
+        <a:font script="Taml" typeface="Latha"/>
+        <a:font script="Syrc" typeface="Estrangelo Edessa"/>
+        <a:font script="Orya" typeface="Kalinga"/>
+        <a:font script="Mlym" typeface="Kartika"/>
+        <a:font script="Laoo" typeface="DokChampa"/>
+        <a:font script="Sinh" typeface="Iskoola Pota"/>
+        <a:font script="Mong" typeface="Mongolian Baiti"/>
+        <a:font script="Viet" typeface="Times New Roman"/>
+        <a:font script="Uigh" typeface="Microsoft Uighur"/>
+        <a:font script="Geor" typeface="Sylfaen"/>
+        <a:font script="Armn" typeface="Arial"/>
+        <a:font script="Bugi" typeface="Leelawadee UI"/>
+        <a:font script="Bopo" typeface="Microsoft JhengHei"/>
+        <a:font script="Java" typeface="Javanese Text"/>
+        <a:font script="Lisu" typeface="Segoe UI"/>
+        <a:font script="Mymr" typeface="Myanmar Text"/>
+        <a:font script="Nkoo" typeface="Ebrima"/>
+        <a:font script="Olck" typeface="Nirmala UI"/>
+        <a:font script="Osma" typeface="Ebrima"/>
+        <a:font script="Phag" typeface="Phagspa"/>
+        <a:font script="Syrn" typeface="Estrangelo Edessa"/>
+        <a:font script="Syrj" typeface="Estrangelo Edessa"/>
+        <a:font script="Syre" typeface="Estrangelo Edessa"/>
+        <a:font script="Sora" typeface="Nirmala UI"/>
+        <a:font script="Tale" typeface="Microsoft Tai Le"/>
+        <a:font script="Talu" typeface="Microsoft New Tai Lue"/>
+        <a:font script="Tfng" typeface="Ebrima"/>
+      </a:majorFont>
+      <a:minorFont>
+        <a:latin typeface="Calibri" panose="020F0502020204030204"/>
+        <a:ea typeface=""/>
+        <a:cs typeface=""/>
+        <a:font script="Jpan" typeface="游ゴシック"/>
+        <a:font script="Hang" typeface="맑은 고딕"/>
+        <a:font script="Hans" typeface="等线"/>
+        <a:font script="Hant" typeface="新細明體"/>
+        <a:font script="Arab" typeface="Arial"/>
+        <a:font script="Hebr" typeface="Arial"/>
+        <a:font script="Thai" typeface="Cordia New"/>
+        <a:font script="Ethi" typeface="Nyala"/>
+        <a:font script="Beng" typeface="Vrinda"/>
+        <a:font script="Gujr" typeface="Shruti"/>
+        <a:font script="Khmr" typeface="DaunPenh"/>
+        <a:font script="Knda" typeface="Tunga"/>
+        <a:font script="Guru" typeface="Raavi"/>
+        <a:font script="Cans" typeface="Euphemia"/>
+        <a:font script="Cher" typeface="Plantagenet Cherokee"/>
+        <a:font script="Yiii" typeface="Microsoft Yi Baiti"/>
+        <a:font script="Tibt" typeface="Microsoft Himalaya"/>
+        <a:font script="Thaa" typeface="MV Boli"/>
+        <a:font script="Deva" typeface="Mangal"/>
+        <a:font script="Telu" typeface="Gautami"/>
+        <a:font script="Taml" typeface="Latha"/>
+        <a:font script="Syrc" typeface="Estrangelo Edessa"/>
+        <a:font script="Orya" typeface="Kalinga"/>
+        <a:font script="Mlym" typeface="Kartika"/>
+        <a:font script="Laoo" typeface="DokChampa"/>
+        <a:font script="Sinh" typeface="Iskoola Pota"/>
+        <a:font script="Mong" typeface="Mongolian Baiti"/>
+        <a:font script="Viet" typeface="Arial"/>
+        <a:font script="Uigh" typeface="Microsoft Uighur"/>
+        <a:font script="Geor" typeface="Sylfaen"/>
+        <a:font script="Armn" typeface="Arial"/>
+        <a:font script="Bugi" typeface="Leelawadee UI"/>
+        <a:font script="Bopo" typeface="Microsoft JhengHei"/>
+        <a:font script="Java" typeface="Javanese Text"/>
+        <a:font script="Lisu" typeface="Segoe UI"/>
+        <a:font script="Mymr" typeface="Myanmar Text"/>
+        <a:font script="Nkoo" typeface="Ebrima"/>
+        <a:font script="Olck" typeface="Nirmala UI"/>
+        <a:font script="Osma" typeface="Ebrima"/>
+        <a:font script="Phag" typeface="Phagspa"/>
+        <a:font script="Syrn" typeface="Estrangelo Edessa"/>
+        <a:font script="Syrj" typeface="Estrangelo Edessa"/>
+        <a:font script="Syre" typeface="Estrangelo Edessa"/>
+        <a:font script="Sora" typeface="Nirmala UI"/>
+        <a:font script="Tale" typeface="Microsoft Tai Le"/>
+        <a:font script="Talu" typeface="Microsoft New Tai Lue"/>
+        <a:font script="Tfng" typeface="Ebrima"/>
+      </a:minorFont>
+    </a:fontScheme>
+    <a:fmtScheme name="Office">
+      <a:fillStyleLst>
+        <a:solidFill>
+          <a:schemeClr val="phClr"/>
+        </a:solidFill>
+        <a:gradFill rotWithShape="1">
+          <a:gsLst>
+            <a:gs pos="0">
+              <a:schemeClr val="phClr">
+                <a:lumMod val="110000"/>
+                <a:satMod val="105000"/>
+                <a:tint val="67000"/>
+              </a:schemeClr>
+            </a:gs>
+            <a:gs pos="50000">
+              <a:schemeClr val="phClr">
+                <a:lumMod val="105000"/>
+                <a:satMod val="103000"/>
+                <a:tint val="73000"/>
+              </a:schemeClr>
+            </a:gs>
+            <a:gs pos="100000">
+              <a:schemeClr val="phClr">
+                <a:lumMod val="105000"/>
+                <a:satMod val="109000"/>
+                <a:tint val="81000"/>
+              </a:schemeClr>
+            </a:gs>
+          </a:gsLst>
+          <a:lin ang="5400000" scaled="0"/>
+        </a:gradFill>
+        <a:gradFill rotWithShape="1">
+          <a:gsLst>
+            <a:gs pos="0">
+              <a:schemeClr val="phClr">
+                <a:satMod val="103000"/>
+                <a:lumMod val="102000"/>
+                <a:tint val="94000"/>
+              </a:schemeClr>
+            </a:gs>
+            <a:gs pos="50000">
+              <a:schemeClr val="phClr">
+                <a:satMod val="110000"/>
+                <a:lumMod val="100000"/>
+                <a:shade val="100000"/>
+              </a:schemeClr>
+            </a:gs>
+            <a:gs pos="100000">
+              <a:schemeClr val="phClr">
+                <a:lumMod val="99000"/>
+                <a:satMod val="120000"/>
+                <a:shade val="78000"/>
+              </a:schemeClr>
+            </a:gs>
+          </a:gsLst>
+          <a:lin ang="5400000" scaled="0"/>
+        </a:gradFill>
+      </a:fillStyleLst>
+      <a:lnStyleLst>
+        <a:ln w="6350" cap="flat" cmpd="sng" algn="ctr">
+          <a:solidFill>
+            <a:schemeClr val="phClr"/>
+          </a:solidFill>
+          <a:prstDash val="solid"/>
+          <a:miter lim="800000"/>
+        </a:ln>
+        <a:ln w="12700" cap="flat" cmpd="sng" algn="ctr">
+          <a:solidFill>
+            <a:schemeClr val="phClr"/>
+          </a:solidFill>
+          <a:prstDash val="solid"/>
+          <a:miter lim="800000"/>
+        </a:ln>
+        <a:ln w="19050" cap="flat" cmpd="sng" algn="ctr">
+          <a:solidFill>
+            <a:schemeClr val="phClr"/>
+          </a:solidFill>
+          <a:prstDash val="solid"/>
+          <a:miter lim="800000"/>
+        </a:ln>
+      </a:lnStyleLst>
+      <a:effectStyleLst>
+        <a:effectStyle>
+          <a:effectLst/>
+        </a:effectStyle>
+        <a:effectStyle>
+          <a:effectLst/>
+        </a:effectStyle>
+        <a:effectStyle>
+          <a:effectLst>
+            <a:outerShdw blurRad="57150" dist="19050" dir="5400000" algn="ctr" rotWithShape="0">
+              <a:srgbClr val="000000">
+                <a:alpha val="63000"/>
+              </a:srgbClr>
+            </a:outerShdw>
+          </a:effectLst>
+        </a:effectStyle>
+      </a:effectStyleLst>
+      <a:bgFillStyleLst>
+        <a:solidFill>
+          <a:schemeClr val="phClr"/>
+        </a:solidFill>
+        <a:solidFill>
+          <a:schemeClr val="phClr">
+            <a:tint val="95000"/>
+            <a:satMod val="170000"/>
+          </a:schemeClr>
+        </a:solidFill>
+        <a:gradFill rotWithShape="1">
+          <a:gsLst>
+            <a:gs pos="0">
+              <a:schemeClr val="phClr">
+                <a:tint val="93000"/>
+                <a:satMod val="150000"/>
+                <a:shade val="98000"/>
+                <a:lumMod val="102000"/>
+              </a:schemeClr>
+            </a:gs>
+            <a:gs pos="50000">
+              <a:schemeClr val="phClr">
+                <a:tint val="98000"/>
+                <a:satMod val="130000"/>
+                <a:shade val="90000"/>
+                <a:lumMod val="103000"/>
+              </a:schemeClr>
+            </a:gs>
+            <a:gs pos="100000">
+              <a:schemeClr val="phClr">
+                <a:shade val="63000"/>
+                <a:satMod val="120000"/>
+              </a:schemeClr>
+            </a:gs>
+          </a:gsLst>
+          <a:lin ang="5400000" scaled="0"/>
+        </a:gradFill>
+      </a:bgFillStyleLst>
+    </a:fmtScheme>
+  </a:themeElements>
+  <a:objectDefaults/>
+  <a:extraClrSchemeLst/>
+  <a:extLst>
+    <a:ext uri="{05A4C25C-085E-4340-85A3-A5531E510DB2}">
+      <thm15:themeFamily xmlns:thm15="http://schemas.microsoft.com/office/thememl/2012/main" name="Office Theme" id="{62F939B6-93AF-4DB8-9C6B-D6C7DFDC589F}" vid="{4A3C46E8-61CC-4603-A589-7422A47A8E4A}"/>
+    </a:ext>
+  </a:extLst>
+</a:theme>
 </file>
</xml_diff>